<commit_message>
Corregir nombre de la materia y agregar link del repo al informe
</commit_message>
<xml_diff>
--- a/docs/presentacion/Presentacion-Reto4-Linkerd.pptx
+++ b/docs/presentacion/Presentacion-Reto4-Linkerd.pptx
@@ -134,20 +134,20 @@
   <p:extLst>
     <p:ext uri="{521415D9-36F7-43E2-AB2F-B90AF26B5E84}">
       <p14:sectionLst xmlns:p14="http://schemas.microsoft.com/office/powerpoint/2010/main">
-        <p14:section name="Inicio" id="{fedf120a-d522-feda-916d-28ac2723bc67}">
+        <p14:section name="Inicio" id="{535eba3a-4f79-89af-56fc-a5d3f73b9b96}">
           <p14:sldIdLst>
             <p14:sldId id="256"/>
             <p14:sldId id="257"/>
           </p14:sldIdLst>
         </p14:section>
-        <p14:section name="Contexto" id="{3a9af1df-a7f5-83e6-9daa-18fb79002dfb}">
+        <p14:section name="Contexto" id="{e06372ff-324c-03f5-3898-f48fe1bd2054}">
           <p14:sldIdLst>
             <p14:sldId id="258"/>
             <p14:sldId id="259"/>
             <p14:sldId id="260"/>
           </p14:sldIdLst>
         </p14:section>
-        <p14:section name="Service Mesh" id="{a1422168-a048-d1e9-7997-77b6f263666f}">
+        <p14:section name="Service Mesh" id="{0f3176b4-9b0f-4def-628e-ff47a77b6a5e}">
           <p14:sldIdLst>
             <p14:sldId id="261"/>
             <p14:sldId id="262"/>
@@ -155,14 +155,14 @@
             <p14:sldId id="264"/>
           </p14:sldIdLst>
         </p14:section>
-        <p14:section name="Arquitectura" id="{ad1bebbc-0161-6cec-ec07-b9559902cc5d}">
+        <p14:section name="Arquitectura" id="{be3d7ead-2e4a-c29b-ba61-2000ddaf30a9}">
           <p14:sldIdLst>
             <p14:sldId id="265"/>
             <p14:sldId id="266"/>
             <p14:sldId id="267"/>
           </p14:sldIdLst>
         </p14:section>
-        <p14:section name="Implementación" id="{f743a5ba-465b-e8d9-611d-54332392d0b6}">
+        <p14:section name="Implementación" id="{c505b6c5-a6be-1ff4-52bb-7165da4f7ec3}">
           <p14:sldIdLst>
             <p14:sldId id="268"/>
             <p14:sldId id="269"/>
@@ -171,7 +171,7 @@
             <p14:sldId id="272"/>
           </p14:sldIdLst>
         </p14:section>
-        <p14:section name="Pruebas" id="{3c6a749e-09ec-111b-0ca8-b7128a616fe7}">
+        <p14:section name="Pruebas" id="{6a5839a2-787b-5751-dc34-eec31bf0d45b}">
           <p14:sldIdLst>
             <p14:sldId id="273"/>
             <p14:sldId id="274"/>
@@ -179,7 +179,7 @@
             <p14:sldId id="276"/>
           </p14:sldIdLst>
         </p14:section>
-        <p14:section name="Observabilidad" id="{59539ca4-6358-5e4b-5f6a-a02b772c5d99}">
+        <p14:section name="Observabilidad" id="{c5f32c47-fdff-3710-594a-03c55fc4c328}">
           <p14:sldIdLst>
             <p14:sldId id="277"/>
             <p14:sldId id="278"/>
@@ -187,7 +187,7 @@
             <p14:sldId id="280"/>
           </p14:sldIdLst>
         </p14:section>
-        <p14:section name="Cierre" id="{f806b056-78c0-f29f-6ea5-1c57cc5cee62}">
+        <p14:section name="Cierre" id="{7b6314ab-9a2a-c516-93dd-56972d08b992}">
           <p14:sldIdLst>
             <p14:sldId id="281"/>
             <p14:sldId id="282"/>
@@ -4232,7 +4232,7 @@
                   <a:srgbClr val="AAB4C3"/>
                 </a:solidFill>
               </a:rPr>
-              <a:t>Principios de Arquitectura de Software · Retos Software III</a:t>
+              <a:t>Principios y Prácticas de Desarrollo de Software Orientado a Objetos</a:t>
             </a:r>
             <a:endParaRPr lang="en-US" sz="1300" dirty="0"/>
           </a:p>

</xml_diff>